<commit_message>
chore(v0.2.22): update API guide and version bump
- Bump version to 0.2.22 in Cargo.toml and Cargo.lock.
- Expand API_GUIDE.md with new sections on Presentation Builder, Charts, Images, Themes & Templates, Export & Compression, Editing Existing Decks, and Package Validation.
- Introduce structured validation CLI output with `--json` option for machine-readable reports.
- Update README.md to reference the new API guide and examples.
- Enhance examples to utilize the simplified API and demonstrate new features.
</commit_message>
<xml_diff>
--- a/examples/output/simple.pptx
+++ b/examples/output/simple.pptx
@@ -1,20 +1,475 @@
 
 <file path=ppt/presentation.xml><?xml version="1.0" encoding="utf-8"?>
-<p:presentation xmlns:a="http://schemas.openxmlformats.org/drawingml/2006/main" xmlns:r="http://schemas.openxmlformats.org/officeDocument/2006/relationships" xmlns:p="http://schemas.openxmlformats.org/presentationml/2006/main" saveSubsetFonts="1">
+<p:presentation xmlns:a="http://schemas.openxmlformats.org/drawingml/2006/main" xmlns:r="http://schemas.openxmlformats.org/officeDocument/2006/relationships" xmlns:p="http://schemas.openxmlformats.org/presentationml/2006/main" saveSubsetFonts="1" autoCompressPictures="0">
   <p:sldMasterIdLst>
     <p:sldMasterId id="2147483648" r:id="rId1"/>
   </p:sldMasterIdLst>
   <p:sldIdLst>
+    <p:sldId id="256" r:id="rId2"/>
     <p:sldId id="257" r:id="rId3"/>
-    <p:sldId id="258" r:id="rId4"/>
-    <p:sldId id="259" r:id="rId5"/>
   </p:sldIdLst>
   <p:sldSz cx="9144000" cy="6858000" type="screen4x3"/>
   <p:notesSz cx="6858000" cy="9144000"/>
+  <p:defaultTextStyle>
+    <a:defPPr>
+      <a:defRPr lang="en-US"/>
+    </a:defPPr>
+    <a:lvl1pPr marL="0" algn="l" defTabSz="457200" rtl="0" eaLnBrk="1" latinLnBrk="0" hangingPunct="1">
+      <a:defRPr sz="1800" kern="1200">
+        <a:solidFill>
+          <a:schemeClr val="tx1"/>
+        </a:solidFill>
+        <a:latin typeface="+mn-lt"/>
+        <a:ea typeface="+mn-ea"/>
+        <a:cs typeface="+mn-cs"/>
+      </a:defRPr>
+    </a:lvl1pPr>
+    <a:lvl2pPr marL="457200" algn="l" defTabSz="457200" rtl="0" eaLnBrk="1" latinLnBrk="0" hangingPunct="1">
+      <a:defRPr sz="1800" kern="1200">
+        <a:solidFill>
+          <a:schemeClr val="tx1"/>
+        </a:solidFill>
+        <a:latin typeface="+mn-lt"/>
+        <a:ea typeface="+mn-ea"/>
+        <a:cs typeface="+mn-cs"/>
+      </a:defRPr>
+    </a:lvl2pPr>
+    <a:lvl3pPr marL="914400" algn="l" defTabSz="457200" rtl="0" eaLnBrk="1" latinLnBrk="0" hangingPunct="1">
+      <a:defRPr sz="1800" kern="1200">
+        <a:solidFill>
+          <a:schemeClr val="tx1"/>
+        </a:solidFill>
+        <a:latin typeface="+mn-lt"/>
+        <a:ea typeface="+mn-ea"/>
+        <a:cs typeface="+mn-cs"/>
+      </a:defRPr>
+    </a:lvl3pPr>
+    <a:lvl4pPr marL="1371600" algn="l" defTabSz="457200" rtl="0" eaLnBrk="1" latinLnBrk="0" hangingPunct="1">
+      <a:defRPr sz="1800" kern="1200">
+        <a:solidFill>
+          <a:schemeClr val="tx1"/>
+        </a:solidFill>
+        <a:latin typeface="+mn-lt"/>
+        <a:ea typeface="+mn-ea"/>
+        <a:cs typeface="+mn-cs"/>
+      </a:defRPr>
+    </a:lvl4pPr>
+    <a:lvl5pPr marL="1828800" algn="l" defTabSz="457200" rtl="0" eaLnBrk="1" latinLnBrk="0" hangingPunct="1">
+      <a:defRPr sz="1800" kern="1200">
+        <a:solidFill>
+          <a:schemeClr val="tx1"/>
+        </a:solidFill>
+        <a:latin typeface="+mn-lt"/>
+        <a:ea typeface="+mn-ea"/>
+        <a:cs typeface="+mn-cs"/>
+      </a:defRPr>
+    </a:lvl5pPr>
+    <a:lvl6pPr marL="2286000" algn="l" defTabSz="457200" rtl="0" eaLnBrk="1" latinLnBrk="0" hangingPunct="1">
+      <a:defRPr sz="1800" kern="1200">
+        <a:solidFill>
+          <a:schemeClr val="tx1"/>
+        </a:solidFill>
+        <a:latin typeface="+mn-lt"/>
+        <a:ea typeface="+mn-ea"/>
+        <a:cs typeface="+mn-cs"/>
+      </a:defRPr>
+    </a:lvl6pPr>
+    <a:lvl7pPr marL="2743200" algn="l" defTabSz="457200" rtl="0" eaLnBrk="1" latinLnBrk="0" hangingPunct="1">
+      <a:defRPr sz="1800" kern="1200">
+        <a:solidFill>
+          <a:schemeClr val="tx1"/>
+        </a:solidFill>
+        <a:latin typeface="+mn-lt"/>
+        <a:ea typeface="+mn-ea"/>
+        <a:cs typeface="+mn-cs"/>
+      </a:defRPr>
+    </a:lvl7pPr>
+    <a:lvl8pPr marL="3200400" algn="l" defTabSz="457200" rtl="0" eaLnBrk="1" latinLnBrk="0" hangingPunct="1">
+      <a:defRPr sz="1800" kern="1200">
+        <a:solidFill>
+          <a:schemeClr val="tx1"/>
+        </a:solidFill>
+        <a:latin typeface="+mn-lt"/>
+        <a:ea typeface="+mn-ea"/>
+        <a:cs typeface="+mn-cs"/>
+      </a:defRPr>
+    </a:lvl8pPr>
+    <a:lvl9pPr marL="3657600" algn="l" defTabSz="457200" rtl="0" eaLnBrk="1" latinLnBrk="0" hangingPunct="1">
+      <a:defRPr sz="1800" kern="1200">
+        <a:solidFill>
+          <a:schemeClr val="tx1"/>
+        </a:solidFill>
+        <a:latin typeface="+mn-lt"/>
+        <a:ea typeface="+mn-ea"/>
+        <a:cs typeface="+mn-cs"/>
+      </a:defRPr>
+    </a:lvl9pPr>
+  </p:defaultTextStyle>
+  <p:extLst>
+    <p:ext uri="{EFAFB233-063F-42B5-8137-9DF3F51BA10A}">
+      <p15:sldGuideLst xmlns:p15="http://schemas.microsoft.com/office/powerpoint/2012/main"/>
+    </p:ext>
+  </p:extLst>
 </p:presentation>
 </file>
 
 <file path=ppt/slideLayouts/slideLayout1.xml><?xml version="1.0" encoding="utf-8"?>
+<p:sldLayout xmlns:a="http://schemas.openxmlformats.org/drawingml/2006/main" xmlns:r="http://schemas.openxmlformats.org/officeDocument/2006/relationships" xmlns:p="http://schemas.openxmlformats.org/presentationml/2006/main" type="title" preserve="1">
+  <p:cSld name="Title Slide">
+    <p:spTree>
+      <p:nvGrpSpPr>
+        <p:cNvPr id="1" name=""/>
+        <p:cNvGrpSpPr/>
+        <p:nvPr/>
+      </p:nvGrpSpPr>
+      <p:grpSpPr>
+        <a:xfrm>
+          <a:off x="0" y="0"/>
+          <a:ext cx="0" cy="0"/>
+          <a:chOff x="0" y="0"/>
+          <a:chExt cx="0" cy="0"/>
+        </a:xfrm>
+      </p:grpSpPr>
+      <p:sp>
+        <p:nvSpPr>
+          <p:cNvPr id="2" name="Title"/>
+          <p:cNvSpPr>
+            <a:spLocks noGrp="1"/>
+          </p:cNvSpPr>
+          <p:nvPr>
+            <p:ph type="ctrTitle"/>
+          </p:nvPr>
+        </p:nvSpPr>
+        <p:spPr>
+          <a:xfrm>
+            <a:off x="1524000" y="1828800"/>
+            <a:ext cx="6096000" cy="1828800"/>
+          </a:xfrm>
+          <a:prstGeom prst="rect">
+            <a:avLst/>
+          </a:prstGeom>
+          <a:noFill/>
+        </p:spPr>
+        <p:txBody>
+          <a:bodyPr/>
+          <a:lstStyle/>
+          <a:p>
+            <a:endParaRPr lang="en-US"/>
+          </a:p>
+        </p:txBody>
+      </p:sp>
+      <p:sp>
+        <p:nvSpPr>
+          <p:cNvPr id="3" name="Subtitle"/>
+          <p:cNvSpPr>
+            <a:spLocks noGrp="1"/>
+          </p:cNvSpPr>
+          <p:nvPr>
+            <p:ph type="subTitle"/>
+          </p:nvPr>
+        </p:nvSpPr>
+        <p:spPr>
+          <a:xfrm>
+            <a:off x="1524000" y="3657600"/>
+            <a:ext cx="6096000" cy="914400"/>
+          </a:xfrm>
+          <a:prstGeom prst="rect">
+            <a:avLst/>
+          </a:prstGeom>
+          <a:noFill/>
+        </p:spPr>
+        <p:txBody>
+          <a:bodyPr/>
+          <a:lstStyle/>
+          <a:p>
+            <a:endParaRPr lang="en-US"/>
+          </a:p>
+        </p:txBody>
+      </p:sp>
+    </p:spTree>
+  </p:cSld>
+  <p:clrMapOvr>
+    <a:masterClrMapping/>
+  </p:clrMapOvr>
+  <p:hf/>
+</p:sldLayout>
+</file>
+
+<file path=ppt/slideLayouts/slideLayout2.xml><?xml version="1.0" encoding="utf-8"?>
+<p:sldLayout xmlns:a="http://schemas.openxmlformats.org/drawingml/2006/main" xmlns:r="http://schemas.openxmlformats.org/officeDocument/2006/relationships" xmlns:p="http://schemas.openxmlformats.org/presentationml/2006/main" type="obj" preserve="1">
+  <p:cSld name="Title and Content">
+    <p:spTree>
+      <p:nvGrpSpPr>
+        <p:cNvPr id="1" name=""/>
+        <p:cNvGrpSpPr/>
+        <p:nvPr/>
+      </p:nvGrpSpPr>
+      <p:grpSpPr>
+        <a:xfrm>
+          <a:off x="0" y="0"/>
+          <a:ext cx="0" cy="0"/>
+          <a:chOff x="0" y="0"/>
+          <a:chExt cx="0" cy="0"/>
+        </a:xfrm>
+      </p:grpSpPr>
+      <p:sp>
+        <p:nvSpPr>
+          <p:cNvPr id="2" name="Title"/>
+          <p:cNvSpPr>
+            <a:spLocks noGrp="1"/>
+          </p:cNvSpPr>
+          <p:nvPr>
+            <p:ph type="title"/>
+          </p:nvPr>
+        </p:nvSpPr>
+        <p:spPr>
+          <a:xfrm>
+            <a:off x="457200" y="274638"/>
+            <a:ext cx="8229600" cy="1143000"/>
+          </a:xfrm>
+          <a:prstGeom prst="rect">
+            <a:avLst/>
+          </a:prstGeom>
+          <a:noFill/>
+        </p:spPr>
+        <p:txBody>
+          <a:bodyPr/>
+          <a:lstStyle/>
+          <a:p>
+            <a:endParaRPr lang="en-US"/>
+          </a:p>
+        </p:txBody>
+      </p:sp>
+      <p:sp>
+        <p:nvSpPr>
+          <p:cNvPr id="3" name="Content"/>
+          <p:cNvSpPr>
+            <a:spLocks noGrp="1"/>
+          </p:cNvSpPr>
+          <p:nvPr>
+            <p:ph type="body" idx="1"/>
+          </p:nvPr>
+        </p:nvSpPr>
+        <p:spPr>
+          <a:xfrm>
+            <a:off x="457200" y="1600200"/>
+            <a:ext cx="8229600" cy="4525963"/>
+          </a:xfrm>
+          <a:prstGeom prst="rect">
+            <a:avLst/>
+          </a:prstGeom>
+          <a:noFill/>
+        </p:spPr>
+        <p:txBody>
+          <a:bodyPr/>
+          <a:lstStyle/>
+          <a:p>
+            <a:endParaRPr lang="en-US"/>
+          </a:p>
+        </p:txBody>
+      </p:sp>
+    </p:spTree>
+  </p:cSld>
+  <p:clrMapOvr>
+    <a:masterClrMapping/>
+  </p:clrMapOvr>
+  <p:hf/>
+</p:sldLayout>
+</file>
+
+<file path=ppt/slideLayouts/slideLayout3.xml><?xml version="1.0" encoding="utf-8"?>
+<p:sldLayout xmlns:a="http://schemas.openxmlformats.org/drawingml/2006/main" xmlns:r="http://schemas.openxmlformats.org/officeDocument/2006/relationships" xmlns:p="http://schemas.openxmlformats.org/presentationml/2006/main" type="twoObj" preserve="1">
+  <p:cSld name="Two Content">
+    <p:spTree>
+      <p:nvGrpSpPr>
+        <p:cNvPr id="1" name=""/>
+        <p:cNvGrpSpPr/>
+        <p:nvPr/>
+      </p:nvGrpSpPr>
+      <p:grpSpPr>
+        <a:xfrm>
+          <a:off x="0" y="0"/>
+          <a:ext cx="0" cy="0"/>
+          <a:chOff x="0" y="0"/>
+          <a:chExt cx="0" cy="0"/>
+        </a:xfrm>
+      </p:grpSpPr>
+      <p:sp>
+        <p:nvSpPr>
+          <p:cNvPr id="2" name="Title"/>
+          <p:cNvSpPr>
+            <a:spLocks noGrp="1"/>
+          </p:cNvSpPr>
+          <p:nvPr>
+            <p:ph type="title"/>
+          </p:nvPr>
+        </p:nvSpPr>
+        <p:spPr>
+          <a:xfrm>
+            <a:off x="457200" y="274638"/>
+            <a:ext cx="8229600" cy="1143000"/>
+          </a:xfrm>
+          <a:prstGeom prst="rect">
+            <a:avLst/>
+          </a:prstGeom>
+          <a:noFill/>
+        </p:spPr>
+        <p:txBody>
+          <a:bodyPr/>
+          <a:lstStyle/>
+          <a:p>
+            <a:endParaRPr lang="en-US"/>
+          </a:p>
+        </p:txBody>
+      </p:sp>
+      <p:sp>
+        <p:nvSpPr>
+          <p:cNvPr id="3" name="Content Left"/>
+          <p:cNvSpPr>
+            <a:spLocks noGrp="1"/>
+          </p:cNvSpPr>
+          <p:nvPr>
+            <p:ph type="body" idx="1"/>
+          </p:nvPr>
+        </p:nvSpPr>
+        <p:spPr>
+          <a:xfrm>
+            <a:off x="457200" y="1600200"/>
+            <a:ext cx="4025400" cy="4525963"/>
+          </a:xfrm>
+          <a:prstGeom prst="rect">
+            <a:avLst/>
+          </a:prstGeom>
+          <a:noFill/>
+        </p:spPr>
+        <p:txBody>
+          <a:bodyPr/>
+          <a:lstStyle/>
+          <a:p>
+            <a:endParaRPr lang="en-US"/>
+          </a:p>
+        </p:txBody>
+      </p:sp>
+      <p:sp>
+        <p:nvSpPr>
+          <p:cNvPr id="4" name="Content Right"/>
+          <p:cNvSpPr>
+            <a:spLocks noGrp="1"/>
+          </p:cNvSpPr>
+          <p:nvPr>
+            <p:ph type="body" idx="2"/>
+          </p:nvPr>
+        </p:nvSpPr>
+        <p:spPr>
+          <a:xfrm>
+            <a:off x="4661400" y="1600200"/>
+            <a:ext cx="4025400" cy="4525963"/>
+          </a:xfrm>
+          <a:prstGeom prst="rect">
+            <a:avLst/>
+          </a:prstGeom>
+          <a:noFill/>
+        </p:spPr>
+        <p:txBody>
+          <a:bodyPr/>
+          <a:lstStyle/>
+          <a:p>
+            <a:endParaRPr lang="en-US"/>
+          </a:p>
+        </p:txBody>
+      </p:sp>
+    </p:spTree>
+  </p:cSld>
+  <p:clrMapOvr>
+    <a:masterClrMapping/>
+  </p:clrMapOvr>
+  <p:hf/>
+</p:sldLayout>
+</file>
+
+<file path=ppt/slideLayouts/slideLayout4.xml><?xml version="1.0" encoding="utf-8"?>
+<p:sldLayout xmlns:a="http://schemas.openxmlformats.org/drawingml/2006/main" xmlns:r="http://schemas.openxmlformats.org/officeDocument/2006/relationships" xmlns:p="http://schemas.openxmlformats.org/presentationml/2006/main" type="secHead" preserve="1">
+  <p:cSld name="Section Header">
+    <p:spTree>
+      <p:nvGrpSpPr>
+        <p:cNvPr id="1" name=""/>
+        <p:cNvGrpSpPr/>
+        <p:nvPr/>
+      </p:nvGrpSpPr>
+      <p:grpSpPr>
+        <a:xfrm>
+          <a:off x="0" y="0"/>
+          <a:ext cx="0" cy="0"/>
+          <a:chOff x="0" y="0"/>
+          <a:chExt cx="0" cy="0"/>
+        </a:xfrm>
+      </p:grpSpPr>
+      <p:sp>
+        <p:nvSpPr>
+          <p:cNvPr id="2" name="Title"/>
+          <p:cNvSpPr>
+            <a:spLocks noGrp="1"/>
+          </p:cNvSpPr>
+          <p:nvPr>
+            <p:ph type="title"/>
+          </p:nvPr>
+        </p:nvSpPr>
+        <p:spPr>
+          <a:xfrm>
+            <a:off x="457200" y="1600200"/>
+            <a:ext cx="8229600" cy="1828800"/>
+          </a:xfrm>
+          <a:prstGeom prst="rect">
+            <a:avLst/>
+          </a:prstGeom>
+          <a:noFill/>
+        </p:spPr>
+        <p:txBody>
+          <a:bodyPr/>
+          <a:lstStyle/>
+          <a:p>
+            <a:endParaRPr lang="en-US"/>
+          </a:p>
+        </p:txBody>
+      </p:sp>
+      <p:sp>
+        <p:nvSpPr>
+          <p:cNvPr id="3" name="Subtitle"/>
+          <p:cNvSpPr>
+            <a:spLocks noGrp="1"/>
+          </p:cNvSpPr>
+          <p:nvPr>
+            <p:ph type="body" idx="1"/>
+          </p:nvPr>
+        </p:nvSpPr>
+        <p:spPr>
+          <a:xfrm>
+            <a:off x="457200" y="3657600"/>
+            <a:ext cx="8229600" cy="1371600"/>
+          </a:xfrm>
+          <a:prstGeom prst="rect">
+            <a:avLst/>
+          </a:prstGeom>
+          <a:noFill/>
+        </p:spPr>
+        <p:txBody>
+          <a:bodyPr/>
+          <a:lstStyle/>
+          <a:p>
+            <a:endParaRPr lang="en-US"/>
+          </a:p>
+        </p:txBody>
+      </p:sp>
+    </p:spTree>
+  </p:cSld>
+  <p:clrMapOvr>
+    <a:masterClrMapping/>
+  </p:clrMapOvr>
+  <p:hf/>
+</p:sldLayout>
+</file>
+
+<file path=ppt/slideLayouts/slideLayout5.xml><?xml version="1.0" encoding="utf-8"?>
 <p:sldLayout xmlns:a="http://schemas.openxmlformats.org/drawingml/2006/main" xmlns:r="http://schemas.openxmlformats.org/officeDocument/2006/relationships" xmlns:p="http://schemas.openxmlformats.org/presentationml/2006/main" type="blank" preserve="1">
   <p:cSld name="Blank">
     <p:spTree>
@@ -36,6 +491,143 @@
   <p:clrMapOvr>
     <a:masterClrMapping/>
   </p:clrMapOvr>
+  <p:hf/>
+</p:sldLayout>
+</file>
+
+<file path=ppt/slideLayouts/slideLayout6.xml><?xml version="1.0" encoding="utf-8"?>
+<p:sldLayout xmlns:a="http://schemas.openxmlformats.org/drawingml/2006/main" xmlns:r="http://schemas.openxmlformats.org/officeDocument/2006/relationships" xmlns:p="http://schemas.openxmlformats.org/presentationml/2006/main" type="titleOnly" preserve="1">
+  <p:cSld name="Title Only">
+    <p:spTree>
+      <p:nvGrpSpPr>
+        <p:cNvPr id="1" name=""/>
+        <p:cNvGrpSpPr/>
+        <p:nvPr/>
+      </p:nvGrpSpPr>
+      <p:grpSpPr>
+        <a:xfrm>
+          <a:off x="0" y="0"/>
+          <a:ext cx="0" cy="0"/>
+          <a:chOff x="0" y="0"/>
+          <a:chExt cx="0" cy="0"/>
+        </a:xfrm>
+      </p:grpSpPr>
+      <p:sp>
+        <p:nvSpPr>
+          <p:cNvPr id="2" name="Title"/>
+          <p:cNvSpPr>
+            <a:spLocks noGrp="1"/>
+          </p:cNvSpPr>
+          <p:nvPr>
+            <p:ph type="title"/>
+          </p:nvPr>
+        </p:nvSpPr>
+        <p:spPr>
+          <a:xfrm>
+            <a:off x="457200" y="274638"/>
+            <a:ext cx="8229600" cy="1143000"/>
+          </a:xfrm>
+          <a:prstGeom prst="rect">
+            <a:avLst/>
+          </a:prstGeom>
+          <a:noFill/>
+        </p:spPr>
+        <p:txBody>
+          <a:bodyPr/>
+          <a:lstStyle/>
+          <a:p>
+            <a:endParaRPr lang="en-US"/>
+          </a:p>
+        </p:txBody>
+      </p:sp>
+    </p:spTree>
+  </p:cSld>
+  <p:clrMapOvr>
+    <a:masterClrMapping/>
+  </p:clrMapOvr>
+  <p:hf/>
+</p:sldLayout>
+</file>
+
+<file path=ppt/slideLayouts/slideLayout7.xml><?xml version="1.0" encoding="utf-8"?>
+<p:sldLayout xmlns:a="http://schemas.openxmlformats.org/drawingml/2006/main" xmlns:r="http://schemas.openxmlformats.org/officeDocument/2006/relationships" xmlns:p="http://schemas.openxmlformats.org/presentationml/2006/main" type="obj" preserve="1">
+  <p:cSld name="Title and Big Content">
+    <p:spTree>
+      <p:nvGrpSpPr>
+        <p:cNvPr id="1" name=""/>
+        <p:cNvGrpSpPr/>
+        <p:nvPr/>
+      </p:nvGrpSpPr>
+      <p:grpSpPr>
+        <a:xfrm>
+          <a:off x="0" y="0"/>
+          <a:ext cx="0" cy="0"/>
+          <a:chOff x="0" y="0"/>
+          <a:chExt cx="0" cy="0"/>
+        </a:xfrm>
+      </p:grpSpPr>
+      <p:sp>
+        <p:nvSpPr>
+          <p:cNvPr id="2" name="Title"/>
+          <p:cNvSpPr>
+            <a:spLocks noGrp="1"/>
+          </p:cNvSpPr>
+          <p:nvPr>
+            <p:ph type="title"/>
+          </p:nvPr>
+        </p:nvSpPr>
+        <p:spPr>
+          <a:xfrm>
+            <a:off x="457200" y="274638"/>
+            <a:ext cx="8229600" cy="800000"/>
+          </a:xfrm>
+          <a:prstGeom prst="rect">
+            <a:avLst/>
+          </a:prstGeom>
+          <a:noFill/>
+        </p:spPr>
+        <p:txBody>
+          <a:bodyPr/>
+          <a:lstStyle/>
+          <a:p>
+            <a:endParaRPr lang="en-US"/>
+          </a:p>
+        </p:txBody>
+      </p:sp>
+      <p:sp>
+        <p:nvSpPr>
+          <p:cNvPr id="3" name="Content"/>
+          <p:cNvSpPr>
+            <a:spLocks noGrp="1"/>
+          </p:cNvSpPr>
+          <p:nvPr>
+            <p:ph type="body" idx="1"/>
+          </p:nvPr>
+        </p:nvSpPr>
+        <p:spPr>
+          <a:xfrm>
+            <a:off x="457200" y="1200000"/>
+            <a:ext cx="8229600" cy="5000000"/>
+          </a:xfrm>
+          <a:prstGeom prst="rect">
+            <a:avLst/>
+          </a:prstGeom>
+          <a:noFill/>
+        </p:spPr>
+        <p:txBody>
+          <a:bodyPr/>
+          <a:lstStyle/>
+          <a:p>
+            <a:endParaRPr lang="en-US"/>
+          </a:p>
+        </p:txBody>
+      </p:sp>
+    </p:spTree>
+  </p:cSld>
+  <p:clrMapOvr>
+    <a:masterClrMapping/>
+  </p:clrMapOvr>
+  <p:hf/>
 </p:sldLayout>
 </file>
 
@@ -66,7 +658,263 @@
   <p:clrMap bg1="lt1" tx1="dk1" bg2="lt2" tx2="dk2" accent1="accent1" accent2="accent2" accent3="accent3" accent4="accent4" accent5="accent5" accent6="accent6" hlink="hlink" folHlink="folHlink"/>
   <p:sldLayoutIdLst>
     <p:sldLayoutId id="2147483649" r:id="rId1"/>
+    <p:sldLayoutId id="2147483650" r:id="rId2"/>
+    <p:sldLayoutId id="2147483651" r:id="rId3"/>
+    <p:sldLayoutId id="2147483652" r:id="rId4"/>
+    <p:sldLayoutId id="2147483653" r:id="rId5"/>
+    <p:sldLayoutId id="2147483654" r:id="rId6"/>
+    <p:sldLayoutId id="2147483655" r:id="rId7"/>
   </p:sldLayoutIdLst>
+  <p:txStyles>
+    <p:titleStyle>
+      <a:lvl1pPr algn="ctr" defTabSz="457200" rtl="0" eaLnBrk="1" latinLnBrk="0" hangingPunct="1">
+        <a:spcBef>
+          <a:spcPct val="0"/>
+        </a:spcBef>
+        <a:buNone/>
+        <a:defRPr sz="4400" kern="1200">
+          <a:solidFill>
+            <a:schemeClr val="tx1"/>
+          </a:solidFill>
+          <a:latin typeface="+mj-lt"/>
+          <a:ea typeface="+mj-ea"/>
+          <a:cs typeface="+mj-cs"/>
+        </a:defRPr>
+      </a:lvl1pPr>
+    </p:titleStyle>
+    <p:bodyStyle>
+      <a:lvl1pPr marL="342900" indent="-342900" algn="l" defTabSz="457200" rtl="0" eaLnBrk="1" latinLnBrk="0" hangingPunct="1">
+        <a:spcBef>
+          <a:spcPct val="20000"/>
+        </a:spcBef>
+        <a:buFont typeface="Arial"/>
+        <a:buChar char="•"/>
+        <a:defRPr sz="3200" kern="1200">
+          <a:solidFill>
+            <a:schemeClr val="tx1"/>
+          </a:solidFill>
+          <a:latin typeface="+mn-lt"/>
+          <a:ea typeface="+mn-ea"/>
+          <a:cs typeface="+mn-cs"/>
+        </a:defRPr>
+      </a:lvl1pPr>
+      <a:lvl2pPr marL="742950" indent="-285750" algn="l" defTabSz="457200" rtl="0" eaLnBrk="1" latinLnBrk="0" hangingPunct="1">
+        <a:spcBef>
+          <a:spcPct val="20000"/>
+        </a:spcBef>
+        <a:buFont typeface="Arial"/>
+        <a:buChar char="–"/>
+        <a:defRPr sz="2800" kern="1200">
+          <a:solidFill>
+            <a:schemeClr val="tx1"/>
+          </a:solidFill>
+          <a:latin typeface="+mn-lt"/>
+          <a:ea typeface="+mn-ea"/>
+          <a:cs typeface="+mn-cs"/>
+        </a:defRPr>
+      </a:lvl2pPr>
+      <a:lvl3pPr marL="1143000" indent="-228600" algn="l" defTabSz="457200" rtl="0" eaLnBrk="1" latinLnBrk="0" hangingPunct="1">
+        <a:spcBef>
+          <a:spcPct val="20000"/>
+        </a:spcBef>
+        <a:buFont typeface="Arial"/>
+        <a:buChar char="•"/>
+        <a:defRPr sz="2400" kern="1200">
+          <a:solidFill>
+            <a:schemeClr val="tx1"/>
+          </a:solidFill>
+          <a:latin typeface="+mn-lt"/>
+          <a:ea typeface="+mn-ea"/>
+          <a:cs typeface="+mn-cs"/>
+        </a:defRPr>
+      </a:lvl3pPr>
+      <a:lvl4pPr marL="1600200" indent="-228600" algn="l" defTabSz="457200" rtl="0" eaLnBrk="1" latinLnBrk="0" hangingPunct="1">
+        <a:spcBef>
+          <a:spcPct val="20000"/>
+        </a:spcBef>
+        <a:buFont typeface="Arial"/>
+        <a:buChar char="–"/>
+        <a:defRPr sz="2000" kern="1200">
+          <a:solidFill>
+            <a:schemeClr val="tx1"/>
+          </a:solidFill>
+          <a:latin typeface="+mn-lt"/>
+          <a:ea typeface="+mn-ea"/>
+          <a:cs typeface="+mn-cs"/>
+        </a:defRPr>
+      </a:lvl4pPr>
+      <a:lvl5pPr marL="2057400" indent="-228600" algn="l" defTabSz="457200" rtl="0" eaLnBrk="1" latinLnBrk="0" hangingPunct="1">
+        <a:spcBef>
+          <a:spcPct val="20000"/>
+        </a:spcBef>
+        <a:buFont typeface="Arial"/>
+        <a:buChar char="»"/>
+        <a:defRPr sz="2000" kern="1200">
+          <a:solidFill>
+            <a:schemeClr val="tx1"/>
+          </a:solidFill>
+          <a:latin typeface="+mn-lt"/>
+          <a:ea typeface="+mn-ea"/>
+          <a:cs typeface="+mn-cs"/>
+        </a:defRPr>
+      </a:lvl5pPr>
+      <a:lvl6pPr marL="2514600" indent="-228600" algn="l" defTabSz="457200" rtl="0" eaLnBrk="1" latinLnBrk="0" hangingPunct="1">
+        <a:spcBef>
+          <a:spcPct val="20000"/>
+        </a:spcBef>
+        <a:buFont typeface="Arial"/>
+        <a:buChar char="•"/>
+        <a:defRPr sz="2000" kern="1200">
+          <a:solidFill>
+            <a:schemeClr val="tx1"/>
+          </a:solidFill>
+          <a:latin typeface="+mn-lt"/>
+          <a:ea typeface="+mn-ea"/>
+          <a:cs typeface="+mn-cs"/>
+        </a:defRPr>
+      </a:lvl6pPr>
+      <a:lvl7pPr marL="2971800" indent="-228600" algn="l" defTabSz="457200" rtl="0" eaLnBrk="1" latinLnBrk="0" hangingPunct="1">
+        <a:spcBef>
+          <a:spcPct val="20000"/>
+        </a:spcBef>
+        <a:buFont typeface="Arial"/>
+        <a:buChar char="•"/>
+        <a:defRPr sz="2000" kern="1200">
+          <a:solidFill>
+            <a:schemeClr val="tx1"/>
+          </a:solidFill>
+          <a:latin typeface="+mn-lt"/>
+          <a:ea typeface="+mn-ea"/>
+          <a:cs typeface="+mn-cs"/>
+        </a:defRPr>
+      </a:lvl7pPr>
+      <a:lvl8pPr marL="3429000" indent="-228600" algn="l" defTabSz="457200" rtl="0" eaLnBrk="1" latinLnBrk="0" hangingPunct="1">
+        <a:spcBef>
+          <a:spcPct val="20000"/>
+        </a:spcBef>
+        <a:buFont typeface="Arial"/>
+        <a:buChar char="•"/>
+        <a:defRPr sz="2000" kern="1200">
+          <a:solidFill>
+            <a:schemeClr val="tx1"/>
+          </a:solidFill>
+          <a:latin typeface="+mn-lt"/>
+          <a:ea typeface="+mn-ea"/>
+          <a:cs typeface="+mn-cs"/>
+        </a:defRPr>
+      </a:lvl8pPr>
+      <a:lvl9pPr marL="3886200" indent="-228600" algn="l" defTabSz="457200" rtl="0" eaLnBrk="1" latinLnBrk="0" hangingPunct="1">
+        <a:spcBef>
+          <a:spcPct val="20000"/>
+        </a:spcBef>
+        <a:buFont typeface="Arial"/>
+        <a:buChar char="•"/>
+        <a:defRPr sz="2000" kern="1200">
+          <a:solidFill>
+            <a:schemeClr val="tx1"/>
+          </a:solidFill>
+          <a:latin typeface="+mn-lt"/>
+          <a:ea typeface="+mn-ea"/>
+          <a:cs typeface="+mn-cs"/>
+        </a:defRPr>
+      </a:lvl9pPr>
+    </p:bodyStyle>
+    <p:otherStyle>
+      <a:defPPr>
+        <a:defRPr lang="en-US"/>
+      </a:defPPr>
+      <a:lvl1pPr marL="0" algn="l" defTabSz="457200" rtl="0" eaLnBrk="1" latinLnBrk="0" hangingPunct="1">
+        <a:defRPr sz="1800" kern="1200">
+          <a:solidFill>
+            <a:schemeClr val="tx1"/>
+          </a:solidFill>
+          <a:latin typeface="+mn-lt"/>
+          <a:ea typeface="+mn-ea"/>
+          <a:cs typeface="+mn-cs"/>
+        </a:defRPr>
+      </a:lvl1pPr>
+      <a:lvl2pPr marL="457200" algn="l" defTabSz="457200" rtl="0" eaLnBrk="1" latinLnBrk="0" hangingPunct="1">
+        <a:defRPr sz="1800" kern="1200">
+          <a:solidFill>
+            <a:schemeClr val="tx1"/>
+          </a:solidFill>
+          <a:latin typeface="+mn-lt"/>
+          <a:ea typeface="+mn-ea"/>
+          <a:cs typeface="+mn-cs"/>
+        </a:defRPr>
+      </a:lvl2pPr>
+      <a:lvl3pPr marL="914400" algn="l" defTabSz="457200" rtl="0" eaLnBrk="1" latinLnBrk="0" hangingPunct="1">
+        <a:defRPr sz="1800" kern="1200">
+          <a:solidFill>
+            <a:schemeClr val="tx1"/>
+          </a:solidFill>
+          <a:latin typeface="+mn-lt"/>
+          <a:ea typeface="+mn-ea"/>
+          <a:cs typeface="+mn-cs"/>
+        </a:defRPr>
+      </a:lvl3pPr>
+      <a:lvl4pPr marL="1371600" algn="l" defTabSz="457200" rtl="0" eaLnBrk="1" latinLnBrk="0" hangingPunct="1">
+        <a:defRPr sz="1800" kern="1200">
+          <a:solidFill>
+            <a:schemeClr val="tx1"/>
+          </a:solidFill>
+          <a:latin typeface="+mn-lt"/>
+          <a:ea typeface="+mn-ea"/>
+          <a:cs typeface="+mn-cs"/>
+        </a:defRPr>
+      </a:lvl4pPr>
+      <a:lvl5pPr marL="1828800" algn="l" defTabSz="457200" rtl="0" eaLnBrk="1" latinLnBrk="0" hangingPunct="1">
+        <a:defRPr sz="1800" kern="1200">
+          <a:solidFill>
+            <a:schemeClr val="tx1"/>
+          </a:solidFill>
+          <a:latin typeface="+mn-lt"/>
+          <a:ea typeface="+mn-ea"/>
+          <a:cs typeface="+mn-cs"/>
+        </a:defRPr>
+      </a:lvl5pPr>
+      <a:lvl6pPr marL="2286000" algn="l" defTabSz="457200" rtl="0" eaLnBrk="1" latinLnBrk="0" hangingPunct="1">
+        <a:defRPr sz="1800" kern="1200">
+          <a:solidFill>
+            <a:schemeClr val="tx1"/>
+          </a:solidFill>
+          <a:latin typeface="+mn-lt"/>
+          <a:ea typeface="+mn-ea"/>
+          <a:cs typeface="+mn-cs"/>
+        </a:defRPr>
+      </a:lvl6pPr>
+      <a:lvl7pPr marL="2743200" algn="l" defTabSz="457200" rtl="0" eaLnBrk="1" latinLnBrk="0" hangingPunct="1">
+        <a:defRPr sz="1800" kern="1200">
+          <a:solidFill>
+            <a:schemeClr val="tx1"/>
+          </a:solidFill>
+          <a:latin typeface="+mn-lt"/>
+          <a:ea typeface="+mn-ea"/>
+          <a:cs typeface="+mn-cs"/>
+        </a:defRPr>
+      </a:lvl7pPr>
+      <a:lvl8pPr marL="3200400" algn="l" defTabSz="457200" rtl="0" eaLnBrk="1" latinLnBrk="0" hangingPunct="1">
+        <a:defRPr sz="1800" kern="1200">
+          <a:solidFill>
+            <a:schemeClr val="tx1"/>
+          </a:solidFill>
+          <a:latin typeface="+mn-lt"/>
+          <a:ea typeface="+mn-ea"/>
+          <a:cs typeface="+mn-cs"/>
+        </a:defRPr>
+      </a:lvl8pPr>
+      <a:lvl9pPr marL="3657600" algn="l" defTabSz="457200" rtl="0" eaLnBrk="1" latinLnBrk="0" hangingPunct="1">
+        <a:defRPr sz="1800" kern="1200">
+          <a:solidFill>
+            <a:schemeClr val="tx1"/>
+          </a:solidFill>
+          <a:latin typeface="+mn-lt"/>
+          <a:ea typeface="+mn-ea"/>
+          <a:cs typeface="+mn-cs"/>
+        </a:defRPr>
+      </a:lvl9pPr>
+    </p:otherStyle>
+  </p:txStyles>
 </p:sldMaster>
 </file>
 
@@ -140,24 +988,30 @@
           <a:bodyPr wrap="square" rtlCol="0"/>
           <a:lstStyle/>
           <a:p>
-            <a:pPr lvl="0"/>
+            <a:pPr lvl="0" marL="457200" indent="-457200">
+              <a:buChar char="•"/>
+            </a:pPr>
             <a:r>
               <a:rPr lang="en-US" sz="2800" b="0" i="0" dirty="0"/>
-              <a:t>Hello, World!</a:t>
+              <a:t>This is my first presentation</a:t>
             </a:r>
           </a:p>
           <a:p>
-            <a:pPr lvl="0"/>
+            <a:pPr lvl="0" marL="457200" indent="-457200">
+              <a:buChar char="•"/>
+            </a:pPr>
             <a:r>
               <a:rPr lang="en-US" sz="2800" b="0" i="0" dirty="0"/>
-              <a:t>This is a simple presentation</a:t>
+              <a:t>Created with ppt-rs</a:t>
             </a:r>
           </a:p>
           <a:p>
-            <a:pPr lvl="0"/>
+            <a:pPr lvl="0" marL="457200" indent="-457200">
+              <a:buChar char="•"/>
+            </a:pPr>
             <a:r>
               <a:rPr lang="en-US" sz="2800" b="0" i="0" dirty="0"/>
-              <a:t>Created with ppt-rs templates</a:t>
+              <a:t>Using the simplified prelude API</a:t>
             </a:r>
           </a:p>
         </p:txBody>
@@ -240,117 +1094,30 @@
           <a:bodyPr wrap="square" rtlCol="0"/>
           <a:lstStyle/>
           <a:p>
-            <a:pPr lvl="0"/>
+            <a:pPr lvl="0" marL="457200" indent="-457200">
+              <a:buChar char="•"/>
+            </a:pPr>
             <a:r>
               <a:rPr lang="en-US" sz="2800" b="0" i="0" dirty="0"/>
-              <a:t>Easy to use API</a:t>
+              <a:t>Easy to use macros</a:t>
             </a:r>
           </a:p>
           <a:p>
-            <a:pPr lvl="0"/>
+            <a:pPr lvl="0" marL="457200" indent="-457200">
+              <a:buChar char="•"/>
+            </a:pPr>
             <a:r>
               <a:rPr lang="en-US" sz="2800" b="0" i="0" dirty="0"/>
-              <a:t>Multiple templates</a:t>
+              <a:t>Fluent builder pattern</a:t>
             </a:r>
           </a:p>
           <a:p>
-            <a:pPr lvl="0"/>
+            <a:pPr lvl="0" marL="457200" indent="-457200">
+              <a:buChar char="•"/>
+            </a:pPr>
             <a:r>
               <a:rPr lang="en-US" sz="2800" b="0" i="0" dirty="0"/>
-              <a:t>Theme support</a:t>
-            </a:r>
-          </a:p>
-        </p:txBody>
-      </p:sp>
-    </p:spTree>
-  </p:cSld>
-  <p:clrMapOvr>
-    <a:masterClrMapping/>
-  </p:clrMapOvr>
-</p:sld>
-</file>
-
-<file path=ppt/slides/slide3.xml><?xml version="1.0" encoding="utf-8"?>
-<p:sld xmlns:a="http://schemas.openxmlformats.org/drawingml/2006/main" xmlns:r="http://schemas.openxmlformats.org/officeDocument/2006/relationships" xmlns:p="http://schemas.openxmlformats.org/presentationml/2006/main">
-  <p:cSld>
-    <p:bg>
-      <p:bgRef idx="1001">
-        <a:schemeClr val="bg1"/>
-      </p:bgRef>
-    </p:bg>
-    <p:spTree>
-      <p:nvGrpSpPr>
-        <p:cNvPr id="1" name=""/>
-        <p:cNvGrpSpPr/>
-        <p:nvPr/>
-      </p:nvGrpSpPr>
-      <p:grpSpPr>
-        <a:xfrm>
-          <a:off x="0" y="0"/>
-          <a:ext cx="9144000" cy="6858000"/>
-          <a:chOff x="0" y="0"/>
-          <a:chExt cx="9144000" cy="6858000"/>
-        </a:xfrm>
-      </p:grpSpPr>
-      <p:sp>
-        <p:nvSpPr>
-          <p:cNvPr id="2" name="Title"/>
-          <p:cNvSpPr txBox="1"/>
-          <p:nvPr/>
-        </p:nvSpPr>
-        <p:spPr>
-          <a:xfrm>
-            <a:off x="457200" y="274638"/>
-            <a:ext cx="8230200" cy="1143000"/>
-          </a:xfrm>
-          <a:prstGeom prst="rect">
-            <a:avLst/>
-          </a:prstGeom>
-          <a:noFill/>
-        </p:spPr>
-        <p:txBody>
-          <a:bodyPr wrap="square" rtlCol="0" anchor="ctr"/>
-          <a:lstStyle/>
-          <a:p>
-            <a:pPr algn="l"/>
-            <a:r>
-              <a:rPr lang="en-US" sz="4400" b="1" i="0" dirty="0"/>
-              <a:t>Conclusion</a:t>
-            </a:r>
-          </a:p>
-        </p:txBody>
-      </p:sp>
-      <p:sp>
-        <p:nvSpPr>
-          <p:cNvPr id="3" name="Content"/>
-          <p:cNvSpPr txBox="1"/>
-          <p:nvPr/>
-        </p:nvSpPr>
-        <p:spPr>
-          <a:xfrm>
-            <a:off x="457200" y="1600200"/>
-            <a:ext cx="8230200" cy="4572000"/>
-          </a:xfrm>
-          <a:prstGeom prst="rect">
-            <a:avLst/>
-          </a:prstGeom>
-          <a:noFill/>
-        </p:spPr>
-        <p:txBody>
-          <a:bodyPr wrap="square" rtlCol="0"/>
-          <a:lstStyle/>
-          <a:p>
-            <a:pPr lvl="0"/>
-            <a:r>
-              <a:rPr lang="en-US" sz="2800" b="0" i="0" dirty="0"/>
-              <a:t>Try ppt-rs today!</a:t>
-            </a:r>
-          </a:p>
-          <a:p>
-            <a:pPr lvl="0"/>
-            <a:r>
-              <a:rPr lang="en-US" sz="2800" b="0" i="0" dirty="0"/>
-              <a:t>Visit github.com/yingkitw/ppt-rs</a:t>
+              <a:t>Type-safe API</a:t>
             </a:r>
           </a:p>
         </p:txBody>
@@ -409,11 +1176,71 @@
         <a:latin typeface="Calibri"/>
         <a:ea typeface=""/>
         <a:cs typeface=""/>
+        <a:font script="Jpan" typeface="ＭＳ Ｐゴシック"/>
+        <a:font script="Hang" typeface="맑은 고딕"/>
+        <a:font script="Hans" typeface="宋体"/>
+        <a:font script="Hant" typeface="新細明體"/>
+        <a:font script="Arab" typeface="Times New Roman"/>
+        <a:font script="Hebr" typeface="Times New Roman"/>
+        <a:font script="Thai" typeface="Angsana New"/>
+        <a:font script="Ethi" typeface="Nyala"/>
+        <a:font script="Beng" typeface="Vrinda"/>
+        <a:font script="Gujr" typeface="Shruti"/>
+        <a:font script="Khmr" typeface="MoolBoran"/>
+        <a:font script="Knda" typeface="Tunga"/>
+        <a:font script="Guru" typeface="Raavi"/>
+        <a:font script="Cans" typeface="Euphemia"/>
+        <a:font script="Cher" typeface="Plantagenet Cherokee"/>
+        <a:font script="Yiii" typeface="Microsoft Yi Baiti"/>
+        <a:font script="Tibt" typeface="Microsoft Himalaya"/>
+        <a:font script="Thaa" typeface="MV Boli"/>
+        <a:font script="Deva" typeface="Mangal"/>
+        <a:font script="Telu" typeface="Gautami"/>
+        <a:font script="Taml" typeface="Latha"/>
+        <a:font script="Syrc" typeface="Estrangelo Edessa"/>
+        <a:font script="Orya" typeface="Kalinga"/>
+        <a:font script="Mlym" typeface="Kartika"/>
+        <a:font script="Laoo" typeface="DokChampa"/>
+        <a:font script="Sinh" typeface="Iskoola Pota"/>
+        <a:font script="Mong" typeface="Mongolian Baiti"/>
+        <a:font script="Viet" typeface="Times New Roman"/>
+        <a:font script="Uigh" typeface="Microsoft Uighur"/>
+        <a:font script="Geor" typeface="Sylfaen"/>
       </a:majorFont>
       <a:minorFont>
         <a:latin typeface="Calibri"/>
         <a:ea typeface=""/>
         <a:cs typeface=""/>
+        <a:font script="Jpan" typeface="ＭＳ Ｐゴシック"/>
+        <a:font script="Hang" typeface="맑은 고딕"/>
+        <a:font script="Hans" typeface="宋体"/>
+        <a:font script="Hant" typeface="新細明體"/>
+        <a:font script="Arab" typeface="Arial"/>
+        <a:font script="Hebr" typeface="Arial"/>
+        <a:font script="Thai" typeface="Cordia New"/>
+        <a:font script="Ethi" typeface="Nyala"/>
+        <a:font script="Beng" typeface="Vrinda"/>
+        <a:font script="Gujr" typeface="Shruti"/>
+        <a:font script="Khmr" typeface="DaunPenh"/>
+        <a:font script="Knda" typeface="Tunga"/>
+        <a:font script="Guru" typeface="Raavi"/>
+        <a:font script="Cans" typeface="Euphemia"/>
+        <a:font script="Cher" typeface="Plantagenet Cherokee"/>
+        <a:font script="Yiii" typeface="Microsoft Yi Baiti"/>
+        <a:font script="Tibt" typeface="Microsoft Himalaya"/>
+        <a:font script="Thaa" typeface="MV Boli"/>
+        <a:font script="Deva" typeface="Mangal"/>
+        <a:font script="Telu" typeface="Gautami"/>
+        <a:font script="Taml" typeface="Latha"/>
+        <a:font script="Syrc" typeface="Estrangelo Edessa"/>
+        <a:font script="Orya" typeface="Kalinga"/>
+        <a:font script="Mlym" typeface="Kartika"/>
+        <a:font script="Laoo" typeface="DokChampa"/>
+        <a:font script="Sinh" typeface="Iskoola Pota"/>
+        <a:font script="Mong" typeface="Mongolian Baiti"/>
+        <a:font script="Viet" typeface="Arial"/>
+        <a:font script="Uigh" typeface="Microsoft Uighur"/>
+        <a:font script="Geor" typeface="Sylfaen"/>
       </a:minorFont>
     </a:fontScheme>
     <a:fmtScheme name="Office">
@@ -448,20 +1275,16 @@
           <a:gsLst>
             <a:gs pos="0">
               <a:schemeClr val="phClr">
-                <a:shade val="51000"/>
-                <a:satMod val="130000"/>
-              </a:schemeClr>
-            </a:gs>
-            <a:gs pos="80000">
-              <a:schemeClr val="phClr">
-                <a:shade val="93000"/>
+                <a:tint val="100000"/>
+                <a:shade val="100000"/>
                 <a:satMod val="130000"/>
               </a:schemeClr>
             </a:gs>
             <a:gs pos="100000">
               <a:schemeClr val="phClr">
-                <a:shade val="94000"/>
-                <a:satMod val="135000"/>
+                <a:tint val="50000"/>
+                <a:shade val="100000"/>
+                <a:satMod val="350000"/>
               </a:schemeClr>
             </a:gs>
           </a:gsLst>
@@ -493,13 +1316,42 @@
       </a:lnStyleLst>
       <a:effectStyleLst>
         <a:effectStyle>
-          <a:effectLst/>
+          <a:effectLst>
+            <a:outerShdw blurRad="40000" dist="20000" dir="5400000" rotWithShape="0">
+              <a:srgbClr val="000000">
+                <a:alpha val="38000"/>
+              </a:srgbClr>
+            </a:outerShdw>
+          </a:effectLst>
         </a:effectStyle>
         <a:effectStyle>
-          <a:effectLst/>
+          <a:effectLst>
+            <a:outerShdw blurRad="40000" dist="23000" dir="5400000" rotWithShape="0">
+              <a:srgbClr val="000000">
+                <a:alpha val="35000"/>
+              </a:srgbClr>
+            </a:outerShdw>
+          </a:effectLst>
         </a:effectStyle>
         <a:effectStyle>
-          <a:effectLst/>
+          <a:effectLst>
+            <a:outerShdw blurRad="40000" dist="23000" dir="5400000" rotWithShape="0">
+              <a:srgbClr val="000000">
+                <a:alpha val="35000"/>
+              </a:srgbClr>
+            </a:outerShdw>
+          </a:effectLst>
+          <a:scene3d>
+            <a:camera prst="orthographicFront">
+              <a:rot lat="0" lon="0" rev="0"/>
+            </a:camera>
+            <a:lightRig rig="threePt" dir="t">
+              <a:rot lat="0" lon="0" rev="1200000"/>
+            </a:lightRig>
+          </a:scene3d>
+          <a:sp3d>
+            <a:bevelT w="63500" h="25400"/>
+          </a:sp3d>
         </a:effectStyle>
       </a:effectStyleLst>
       <a:bgFillStyleLst>
@@ -554,7 +1406,46 @@
       </a:bgFillStyleLst>
     </a:fmtScheme>
   </a:themeElements>
-  <a:objectDefaults/>
+  <a:objectDefaults>
+    <a:spDef>
+      <a:spPr/>
+      <a:bodyPr/>
+      <a:lstStyle/>
+      <a:style>
+        <a:lnRef idx="1">
+          <a:schemeClr val="accent1"/>
+        </a:lnRef>
+        <a:fillRef idx="3">
+          <a:schemeClr val="accent1"/>
+        </a:fillRef>
+        <a:effectRef idx="2">
+          <a:schemeClr val="accent1"/>
+        </a:effectRef>
+        <a:fontRef idx="minor">
+          <a:schemeClr val="lt1"/>
+        </a:fontRef>
+      </a:style>
+    </a:spDef>
+    <a:lnDef>
+      <a:spPr/>
+      <a:bodyPr/>
+      <a:lstStyle/>
+      <a:style>
+        <a:lnRef idx="2">
+          <a:schemeClr val="accent1"/>
+        </a:lnRef>
+        <a:fillRef idx="0">
+          <a:schemeClr val="accent1"/>
+        </a:fillRef>
+        <a:effectRef idx="1">
+          <a:schemeClr val="accent1"/>
+        </a:effectRef>
+        <a:fontRef idx="minor">
+          <a:schemeClr val="tx1"/>
+        </a:fontRef>
+      </a:style>
+    </a:lnDef>
+  </a:objectDefaults>
   <a:extraClrSchemeLst/>
 </a:theme>
 </file>
</xml_diff>